<commit_message>
Add instructions edit ppt
</commit_message>
<xml_diff>
--- a/gxls-copilot-studio-excel.pptx
+++ b/gxls-copilot-studio-excel.pptx
@@ -246,7 +246,7 @@
           <a:p>
             <a:fld id="{17A98A70-FA8C-4354-959C-C70678AC9BCF}" type="datetimeFigureOut">
               <a:rPr lang="en-US" smtClean="0"/>
-              <a:t>3/4/2026</a:t>
+              <a:t>3/12/2026</a:t>
             </a:fld>
             <a:endParaRPr lang="en-US"/>
           </a:p>
@@ -1347,7 +1347,7 @@
             <a:fld id="{1D8BD707-D9CF-40AE-B4C6-C98DA3205C09}" type="datetimeFigureOut">
               <a:rPr lang="en-US" smtClean="0"/>
               <a:pPr/>
-              <a:t>3/4/2026</a:t>
+              <a:t>3/12/2026</a:t>
             </a:fld>
             <a:endParaRPr lang="en-US"/>
           </a:p>
@@ -1512,7 +1512,7 @@
             <a:fld id="{1D8BD707-D9CF-40AE-B4C6-C98DA3205C09}" type="datetimeFigureOut">
               <a:rPr lang="en-US" smtClean="0"/>
               <a:pPr/>
-              <a:t>3/4/2026</a:t>
+              <a:t>3/12/2026</a:t>
             </a:fld>
             <a:endParaRPr lang="en-US"/>
           </a:p>
@@ -1687,7 +1687,7 @@
             <a:fld id="{1D8BD707-D9CF-40AE-B4C6-C98DA3205C09}" type="datetimeFigureOut">
               <a:rPr lang="en-US" smtClean="0"/>
               <a:pPr/>
-              <a:t>3/4/2026</a:t>
+              <a:t>3/12/2026</a:t>
             </a:fld>
             <a:endParaRPr lang="en-US"/>
           </a:p>
@@ -1852,7 +1852,7 @@
             <a:fld id="{1D8BD707-D9CF-40AE-B4C6-C98DA3205C09}" type="datetimeFigureOut">
               <a:rPr lang="en-US" smtClean="0"/>
               <a:pPr/>
-              <a:t>3/4/2026</a:t>
+              <a:t>3/12/2026</a:t>
             </a:fld>
             <a:endParaRPr lang="en-US"/>
           </a:p>
@@ -2094,7 +2094,7 @@
             <a:fld id="{1D8BD707-D9CF-40AE-B4C6-C98DA3205C09}" type="datetimeFigureOut">
               <a:rPr lang="en-US" smtClean="0"/>
               <a:pPr/>
-              <a:t>3/4/2026</a:t>
+              <a:t>3/12/2026</a:t>
             </a:fld>
             <a:endParaRPr lang="en-US"/>
           </a:p>
@@ -2376,7 +2376,7 @@
             <a:fld id="{1D8BD707-D9CF-40AE-B4C6-C98DA3205C09}" type="datetimeFigureOut">
               <a:rPr lang="en-US" smtClean="0"/>
               <a:pPr/>
-              <a:t>3/4/2026</a:t>
+              <a:t>3/12/2026</a:t>
             </a:fld>
             <a:endParaRPr lang="en-US"/>
           </a:p>
@@ -2792,7 +2792,7 @@
             <a:fld id="{1D8BD707-D9CF-40AE-B4C6-C98DA3205C09}" type="datetimeFigureOut">
               <a:rPr lang="en-US" smtClean="0"/>
               <a:pPr/>
-              <a:t>3/4/2026</a:t>
+              <a:t>3/12/2026</a:t>
             </a:fld>
             <a:endParaRPr lang="en-US"/>
           </a:p>
@@ -2906,7 +2906,7 @@
             <a:fld id="{1D8BD707-D9CF-40AE-B4C6-C98DA3205C09}" type="datetimeFigureOut">
               <a:rPr lang="en-US" smtClean="0"/>
               <a:pPr/>
-              <a:t>3/4/2026</a:t>
+              <a:t>3/12/2026</a:t>
             </a:fld>
             <a:endParaRPr lang="en-US"/>
           </a:p>
@@ -2998,7 +2998,7 @@
             <a:fld id="{1D8BD707-D9CF-40AE-B4C6-C98DA3205C09}" type="datetimeFigureOut">
               <a:rPr lang="en-US" smtClean="0"/>
               <a:pPr/>
-              <a:t>3/4/2026</a:t>
+              <a:t>3/12/2026</a:t>
             </a:fld>
             <a:endParaRPr lang="en-US"/>
           </a:p>
@@ -3270,7 +3270,7 @@
             <a:fld id="{1D8BD707-D9CF-40AE-B4C6-C98DA3205C09}" type="datetimeFigureOut">
               <a:rPr lang="en-US" smtClean="0"/>
               <a:pPr/>
-              <a:t>3/4/2026</a:t>
+              <a:t>3/12/2026</a:t>
             </a:fld>
             <a:endParaRPr lang="en-US"/>
           </a:p>
@@ -3519,7 +3519,7 @@
             <a:fld id="{1D8BD707-D9CF-40AE-B4C6-C98DA3205C09}" type="datetimeFigureOut">
               <a:rPr lang="en-US" smtClean="0"/>
               <a:pPr/>
-              <a:t>3/4/2026</a:t>
+              <a:t>3/12/2026</a:t>
             </a:fld>
             <a:endParaRPr lang="en-US"/>
           </a:p>
@@ -3732,7 +3732,7 @@
             <a:fld id="{1D8BD707-D9CF-40AE-B4C6-C98DA3205C09}" type="datetimeFigureOut">
               <a:rPr lang="en-US" smtClean="0"/>
               <a:pPr/>
-              <a:t>3/4/2026</a:t>
+              <a:t>3/12/2026</a:t>
             </a:fld>
             <a:endParaRPr lang="en-US"/>
           </a:p>
@@ -6385,7 +6385,7 @@
                 <a:latin typeface="Pragmatica" panose="020B0403040502020204"/>
                 <a:sym typeface="Consolas"/>
               </a:rPr>
-              <a:t>Create Excel MVP knowledge base with Copilot Studio</a:t>
+              <a:t>Create Excel MVP knowledge base with Agent Builder</a:t>
             </a:r>
           </a:p>
           <a:p>

</xml_diff>